<commit_message>
Rename Data Atlas to Transformation and Mapping Catalog across all docs
Corrects terminology in all source markdown files, build scripts, and
regenerated .docx and .pptx binaries. 37 occurrences replaced, zero remaining.

Co-Authored-By: Claude Opus 4.6 <noreply@anthropic.com>
</commit_message>
<xml_diff>
--- a/docs/Agentic_Health_Interop_Engineering.pptx
+++ b/docs/Agentic_Health_Interop_Engineering.pptx
@@ -3810,7 +3810,7 @@
               </a:defRPr>
             </a:pPr>
             <a:r>
-              <a:t>FHIR STU3 and CDA Data Atlas coverage</a:t>
+              <a:t>FHIR STU3 and CDA Transformation and Mapping Catalog coverage</a:t>
             </a:r>
           </a:p>
           <a:p>
@@ -9569,7 +9569,7 @@
               </a:defRPr>
             </a:pPr>
             <a:r>
-              <a:t>Data Atlas (1,538 field mappings)</a:t>
+              <a:t>Transformation and Mapping Catalog (1,538 field mappings)</a:t>
             </a:r>
           </a:p>
           <a:p>

</xml_diff>

<commit_message>
Replace fabricated metrics with real measured data across 4 decks
The "50% token cost reduction" and before/after performance table
had no defensible baseline — they were invented for the slides.
Replaced with actual measured data from live agent runs:

- Simple query: 16,690 tokens, 14s (measured)
- ADT build planning turn: 32,794 tokens, 25s (measured)
- Full build estimate: 80-150K tokens, 2-5 min, $0.30-$0.75
- Comparison: vs. 2-3 days of senior engineer labor

Files updated:
- President slide 12: "50% reduction" -> "Under $1 per build"
- VP UseCase slide 10: "50% Token Reduction" -> "Under $1 Per Build"
- Engineering slide 9: fabricated before/after table replaced with
  measured token usage table citing data source for each row
- Executive slide 7: "10x faster" -> measured timing

Also adds docs/diagrams/architecture_v2.html with improved
five-layer architecture diagram using IS brand colors.

Co-Authored-By: Claude Opus 4.6 <noreply@anthropic.com>
</commit_message>
<xml_diff>
--- a/docs/Agentic_Health_Interop_Engineering.pptx
+++ b/docs/Agentic_Health_Interop_Engineering.pptx
@@ -10556,7 +10556,7 @@
               </a:defRPr>
             </a:pPr>
             <a:r>
-              <a:t>Performance: Token Optimization Results</a:t>
+              <a:t>Performance: Measured Token Usage</a:t>
             </a:r>
           </a:p>
         </p:txBody>
@@ -10671,7 +10671,7 @@
               </a:defRPr>
             </a:pPr>
             <a:r>
-              <a:t>Before</a:t>
+              <a:t>Measured</a:t>
             </a:r>
           </a:p>
         </p:txBody>
@@ -10707,7 +10707,7 @@
               </a:defRPr>
             </a:pPr>
             <a:r>
-              <a:t>After</a:t>
+              <a:t>Context</a:t>
             </a:r>
           </a:p>
         </p:txBody>
@@ -10743,7 +10743,7 @@
               </a:defRPr>
             </a:pPr>
             <a:r>
-              <a:t>Improvement</a:t>
+              <a:t>Source</a:t>
             </a:r>
           </a:p>
         </p:txBody>
@@ -10822,7 +10822,7 @@
               </a:defRPr>
             </a:pPr>
             <a:r>
-              <a:t>Tool catalog tokens</a:t>
+              <a:t>Simple query (total)</a:t>
             </a:r>
           </a:p>
         </p:txBody>
@@ -10858,7 +10858,7 @@
               </a:defRPr>
             </a:pPr>
             <a:r>
-              <a:t>~15K</a:t>
+              <a:t>16,690</a:t>
             </a:r>
           </a:p>
         </p:txBody>
@@ -10894,7 +10894,7 @@
               </a:defRPr>
             </a:pPr>
             <a:r>
-              <a:t>~10K</a:t>
+              <a:t>14 seconds</a:t>
             </a:r>
           </a:p>
         </p:txBody>
@@ -10930,7 +10930,7 @@
               </a:defRPr>
             </a:pPr>
             <a:r>
-              <a:t>-33%</a:t>
+              <a:t>Measured</a:t>
             </a:r>
           </a:p>
         </p:txBody>
@@ -11009,7 +11009,7 @@
               </a:defRPr>
             </a:pPr>
             <a:r>
-              <a:t>System prompt tokens</a:t>
+              <a:t>Planning turn (ADT build)</a:t>
             </a:r>
           </a:p>
         </p:txBody>
@@ -11045,7 +11045,7 @@
               </a:defRPr>
             </a:pPr>
             <a:r>
-              <a:t>~5K</a:t>
+              <a:t>32,794</a:t>
             </a:r>
           </a:p>
         </p:txBody>
@@ -11081,7 +11081,7 @@
               </a:defRPr>
             </a:pPr>
             <a:r>
-              <a:t>~2K</a:t>
+              <a:t>25 seconds</a:t>
             </a:r>
           </a:p>
         </p:txBody>
@@ -11117,7 +11117,7 @@
               </a:defRPr>
             </a:pPr>
             <a:r>
-              <a:t>-60%</a:t>
+              <a:t>Measured</a:t>
             </a:r>
           </a:p>
         </p:txBody>
@@ -11196,7 +11196,7 @@
               </a:defRPr>
             </a:pPr>
             <a:r>
-              <a:t>Simple query (total)</a:t>
+              <a:t>Full build (est. 3-5 turns)</a:t>
             </a:r>
           </a:p>
         </p:txBody>
@@ -11232,7 +11232,7 @@
               </a:defRPr>
             </a:pPr>
             <a:r>
-              <a:t>~25K</a:t>
+              <a:t>80-150K</a:t>
             </a:r>
           </a:p>
         </p:txBody>
@@ -11268,7 +11268,7 @@
               </a:defRPr>
             </a:pPr>
             <a:r>
-              <a:t>~15K</a:t>
+              <a:t>2-5 minutes</a:t>
             </a:r>
           </a:p>
         </p:txBody>
@@ -11304,7 +11304,7 @@
               </a:defRPr>
             </a:pPr>
             <a:r>
-              <a:t>-40%</a:t>
+              <a:t>Estimated</a:t>
             </a:r>
           </a:p>
         </p:txBody>
@@ -11383,7 +11383,7 @@
               </a:defRPr>
             </a:pPr>
             <a:r>
-              <a:t>Complex task (total)</a:t>
+              <a:t>Cost per build (Bedrock)</a:t>
             </a:r>
           </a:p>
         </p:txBody>
@@ -11419,7 +11419,7 @@
               </a:defRPr>
             </a:pPr>
             <a:r>
-              <a:t>~120K</a:t>
+              <a:t>$0.30-$0.75</a:t>
             </a:r>
           </a:p>
         </p:txBody>
@@ -11455,7 +11455,7 @@
               </a:defRPr>
             </a:pPr>
             <a:r>
-              <a:t>~50K</a:t>
+              <a:t>vs. 2-3 days labor</a:t>
             </a:r>
           </a:p>
         </p:txBody>
@@ -11491,7 +11491,7 @@
               </a:defRPr>
             </a:pPr>
             <a:r>
-              <a:t>-58%</a:t>
+              <a:t>Calculated</a:t>
             </a:r>
           </a:p>
         </p:txBody>
@@ -11570,7 +11570,7 @@
               </a:defRPr>
             </a:pPr>
             <a:r>
-              <a:t>Simple query latency</a:t>
+              <a:t>Tools called per turn</a:t>
             </a:r>
           </a:p>
         </p:txBody>
@@ -11606,7 +11606,7 @@
               </a:defRPr>
             </a:pPr>
             <a:r>
-              <a:t>8-12s</a:t>
+              <a:t>2-6</a:t>
             </a:r>
           </a:p>
         </p:txBody>
@@ -11642,7 +11642,7 @@
               </a:defRPr>
             </a:pPr>
             <a:r>
-              <a:t>3-5s</a:t>
+              <a:t>42 available</a:t>
             </a:r>
           </a:p>
         </p:txBody>
@@ -11678,7 +11678,7 @@
               </a:defRPr>
             </a:pPr>
             <a:r>
-              <a:t>-60%</a:t>
+              <a:t>Measured</a:t>
             </a:r>
           </a:p>
         </p:txBody>
@@ -11757,7 +11757,7 @@
               </a:defRPr>
             </a:pPr>
             <a:r>
-              <a:t>Complex task latency</a:t>
+              <a:t>Skills loaded per build</a:t>
             </a:r>
           </a:p>
         </p:txBody>
@@ -11793,7 +11793,7 @@
               </a:defRPr>
             </a:pPr>
             <a:r>
-              <a:t>90s+</a:t>
+              <a:t>3-5</a:t>
             </a:r>
           </a:p>
         </p:txBody>
@@ -11829,7 +11829,7 @@
               </a:defRPr>
             </a:pPr>
             <a:r>
-              <a:t>45-60s</a:t>
+              <a:t>of 12 total</a:t>
             </a:r>
           </a:p>
         </p:txBody>
@@ -11865,7 +11865,7 @@
               </a:defRPr>
             </a:pPr>
             <a:r>
-              <a:t>-40%</a:t>
+              <a:t>On-demand</a:t>
             </a:r>
           </a:p>
         </p:txBody>
@@ -11901,7 +11901,7 @@
               </a:defRPr>
             </a:pPr>
             <a:r>
-              <a:t>Six optimization strategies applied:</a:t>
+              <a:t>Cost control strategies (all implemented and active):</a:t>
             </a:r>
           </a:p>
         </p:txBody>
@@ -11937,7 +11937,7 @@
               </a:defRPr>
             </a:pPr>
             <a:r>
-              <a:t>ToolFilter policy: strips 15 framework waste tools before each LLM call</a:t>
+              <a:t>ToolFilter policy: strips FileSystem, SQL, Shell tools from LLM catalog on every turn</a:t>
             </a:r>
           </a:p>
         </p:txBody>
@@ -11973,7 +11973,7 @@
               </a:defRPr>
             </a:pPr>
             <a:r>
-              <a:t>Concise tool descriptions: imperative contracts instead of verbose explanations</a:t>
+              <a:t>On-demand skills: only the domains the task needs are loaded (e.g. ADT build loads 4 of 12)</a:t>
             </a:r>
           </a:p>
         </p:txBody>
@@ -12009,7 +12009,7 @@
               </a:defRPr>
             </a:pPr>
             <a:r>
-              <a:t>No markdown in responses: eliminates rendering bugs in chat UI</a:t>
+              <a:t>Monitor token budget: 100K cap per turn prevents runaway costs on stuck iterations</a:t>
             </a:r>
           </a:p>
         </p:txBody>
@@ -12045,7 +12045,7 @@
               </a:defRPr>
             </a:pPr>
             <a:r>
-              <a:t>Monitor token budget: 50K cap per turn prevents runaway costs</a:t>
+              <a:t>Rate-limit retry: exponential backoff on Bedrock 429s (30s/60s/90s) with user-visible status</a:t>
             </a:r>
           </a:p>
         </p:txBody>
@@ -12081,7 +12081,7 @@
               </a:defRPr>
             </a:pPr>
             <a:r>
-              <a:t>Multi-turn task decomposition: research -&gt; propose -&gt; build -&gt; validate -&gt; report</a:t>
+              <a:t>Compact system prompt: &lt; 2K tokens. Domain knowledge lives in Skills, not in the base prompt</a:t>
             </a:r>
           </a:p>
         </p:txBody>
@@ -12117,7 +12117,7 @@
               </a:defRPr>
             </a:pPr>
             <a:r>
-              <a:t>Compact system prompt: &lt; 2K tokens; domain knowledge lives in Skills, not in prompt</a:t>
+              <a:t>Fabrication guard: detects claims without tool calls and forces retry before reporting success</a:t>
             </a:r>
           </a:p>
         </p:txBody>

</xml_diff>